<commit_message>
Rebrand to Brick Industries Telangana (decks, poster, docs, filenames)
Co-Authored-By: Claude Opus 4.8 <noreply@anthropic.com>
</commit_message>
<xml_diff>
--- a/startup/Mud_Interlocking_Comparison.pptx
+++ b/startup/Mud_Interlocking_Comparison.pptx
@@ -2614,7 +2614,7 @@
         <p:spPr>
           <a:xfrm>
             <a:off x="566928" y="4434840"/>
-            <a:ext cx="5486400" cy="274320"/>
+            <a:ext cx="6400800" cy="274320"/>
           </a:xfrm>
           <a:prstGeom prst="rect">
             <a:avLst/>
@@ -2630,7 +2630,7 @@
               <a:buNone/>
             </a:pPr>
             <a:r>
-              <a:rPr lang="en-US" sz="1200" b="1" spc="300" kern="0" dirty="0">
+              <a:rPr lang="en-US" sz="1200" b="1" spc="200" kern="0" dirty="0">
                 <a:solidFill>
                   <a:srgbClr val="5C8A5A"/>
                 </a:solidFill>
@@ -2638,7 +2638,7 @@
                 <a:ea typeface="Calibri" pitchFamily="34" charset="-122"/>
                 <a:cs typeface="Calibri" pitchFamily="34" charset="-120"/>
               </a:rPr>
-              <a:t>TERRABLOCK  ·  TELANGANA</a:t>
+              <a:t>BRICK INDUSTRIES TELANGANA</a:t>
             </a:r>
             <a:endParaRPr lang="en-US" sz="1200" dirty="0"/>
           </a:p>

</xml_diff>